<commit_message>
Add cumulative MATLAB DNA storage checkpoints
</commit_message>
<xml_diff>
--- a/courses/molecular-information-engineering/week04/dna-storage/downloads/DNA_storage_encoding_decoding_4week.pptx
+++ b/courses/molecular-information-engineering/week04/dna-storage/downloads/DNA_storage_encoding_decoding_4week.pptx
@@ -5155,7 +5155,7 @@
                 </a:solidFill>
                 <a:latin typeface="Noto Sans CJK KR"/>
               </a:rPr>
-              <a:t>한 스크립트의 섹션이 입력, 행 분할, XOR, index/RS, DNA/FASTA 순서로 이어집니다.</a:t>
+              <a:t>각 번호 파일은 앞 코드 블록을 누적한 독립 실행본이며, 실행 로그 PASS를 확인하고 다음 단계로 이동합니다.</a:t>
             </a:r>
           </a:p>
         </p:txBody>
@@ -6701,7 +6701,7 @@
                 </a:solidFill>
                 <a:latin typeface="Noto Sans CJK KR"/>
               </a:rPr>
-              <a:t>출력 로그에서 원본 길이 L, 짝수 행 수 D, ext를 기록해 디코더에 입력</a:t>
+              <a:t>Encoding_1.m → 1-2.m → 1-3.m → 1-4.m → 1-5.m → 1-6.m 순서로 실행</a:t>
             </a:r>
           </a:p>
         </p:txBody>
@@ -12504,7 +12504,7 @@
                 </a:solidFill>
                 <a:latin typeface="Noto Sans CJK KR"/>
               </a:rPr>
-              <a:t>MATLAB R2026a Online 실검증 로그는 업로드 후 마지막에 추가합니다.</a:t>
+              <a:t>MATLAB Online R2026a: L=13 · D=2 · 3 strands · 148 nt · decoded.txt = 송영준 DNA</a:t>
             </a:r>
           </a:p>
         </p:txBody>
@@ -13015,7 +13015,7 @@
                 </a:solidFill>
                 <a:latin typeface="Noto Sans CJK KR"/>
               </a:rPr>
-              <a:t>4.  FASTA를 디코더 inputFile에 설정</a:t>
+              <a:t>4.  dnas_sequences.txt 또는 FASTA를 디코더에 설정</a:t>
             </a:r>
           </a:p>
         </p:txBody>
@@ -13050,7 +13050,7 @@
                 </a:solidFill>
                 <a:latin typeface="Noto Sans CJK KR"/>
               </a:rPr>
-              <a:t>5.  같은 L / D / ext를 복사해 Run</a:t>
+              <a:t>5.  L / D / ext를 복사 → decoded 파일 생성</a:t>
             </a:r>
           </a:p>
         </p:txBody>

</xml_diff>